<commit_message>
Atualiza planilha e roteiro 22/10/2026 14:38
</commit_message>
<xml_diff>
--- a/dados/roteiro.pptx
+++ b/dados/roteiro.pptx
@@ -3687,13 +3687,18 @@
               <a:t>Total de </a:t>
             </a:r>
             <a:r>
-              <a:rPr lang="pt-BR" dirty="0" err="1" smtClean="0"/>
-              <a:t>xxxx</a:t>
-            </a:r>
-            <a:r>
               <a:rPr lang="pt-BR" dirty="0" smtClean="0"/>
-              <a:t> Novas posições:</a:t>
-            </a:r>
+              <a:t>ao menos 3192 </a:t>
+            </a:r>
+            <a:r>
+              <a:rPr lang="pt-BR" dirty="0"/>
+              <a:t>n</a:t>
+            </a:r>
+            <a:r>
+              <a:rPr lang="pt-BR" dirty="0" smtClean="0"/>
+              <a:t>ovas posições.</a:t>
+            </a:r>
+            <a:endParaRPr lang="pt-BR" dirty="0" smtClean="0"/>
           </a:p>
           <a:p>
             <a:pPr marL="0" indent="0">

</xml_diff>